<commit_message>
Open Decisions: remove 13 superseded options; smaller big numbers on Spotlight by $
Co-Authored-By: Claude Opus 5.5 <noreply@anthropic.com>
Claude-Session: https://claude.ai/code/session_01Xa4nFVxuQGXmHARGph9WhS
</commit_message>
<xml_diff>
--- a/day2-deck/decks/Store Records - Review.pptx
+++ b/day2-deck/decks/Store Records - Review.pptx
@@ -8983,7 +8983,7 @@
               <a:buNone/>
             </a:pPr>
             <a:r>
-              <a:rPr lang="en-US" sz="4000" b="1" dirty="0">
+              <a:rPr lang="en-US" sz="3200" b="1" dirty="0">
                 <a:solidFill>
                   <a:srgbClr val="0B7A4A"/>
                 </a:solidFill>
@@ -8993,7 +8993,7 @@
               </a:rPr>
               <a:t>+$1.77M</a:t>
             </a:r>
-            <a:endParaRPr lang="en-US" sz="4000" dirty="0"/>
+            <a:endParaRPr lang="en-US" sz="3200" dirty="0"/>
           </a:p>
         </p:txBody>
       </p:sp>
@@ -9142,7 +9142,7 @@
               <a:buNone/>
             </a:pPr>
             <a:r>
-              <a:rPr lang="en-US" sz="4000" b="1" dirty="0">
+              <a:rPr lang="en-US" sz="3200" b="1" dirty="0">
                 <a:solidFill>
                   <a:srgbClr val="0B7A4A"/>
                 </a:solidFill>
@@ -9152,7 +9152,7 @@
               </a:rPr>
               <a:t>+$1.70M</a:t>
             </a:r>
-            <a:endParaRPr lang="en-US" sz="4000" dirty="0"/>
+            <a:endParaRPr lang="en-US" sz="3200" dirty="0"/>
           </a:p>
         </p:txBody>
       </p:sp>
@@ -9301,7 +9301,7 @@
               <a:buNone/>
             </a:pPr>
             <a:r>
-              <a:rPr lang="en-US" sz="4000" b="1" dirty="0">
+              <a:rPr lang="en-US" sz="3200" b="1" dirty="0">
                 <a:solidFill>
                   <a:srgbClr val="0B7A4A"/>
                 </a:solidFill>
@@ -9311,7 +9311,7 @@
               </a:rPr>
               <a:t>+$0.76M</a:t>
             </a:r>
-            <a:endParaRPr lang="en-US" sz="4000" dirty="0"/>
+            <a:endParaRPr lang="en-US" sz="3200" dirty="0"/>
           </a:p>
         </p:txBody>
       </p:sp>
@@ -9460,7 +9460,7 @@
               <a:buNone/>
             </a:pPr>
             <a:r>
-              <a:rPr lang="en-US" sz="4000" b="1" dirty="0">
+              <a:rPr lang="en-US" sz="3200" b="1" dirty="0">
                 <a:solidFill>
                   <a:srgbClr val="0B7A4A"/>
                 </a:solidFill>
@@ -9470,7 +9470,7 @@
               </a:rPr>
               <a:t>+$0.72M</a:t>
             </a:r>
-            <a:endParaRPr lang="en-US" sz="4000" dirty="0"/>
+            <a:endParaRPr lang="en-US" sz="3200" dirty="0"/>
           </a:p>
         </p:txBody>
       </p:sp>

</xml_diff>